<commit_message>
docs: refresh README changelog and release workflow
</commit_message>
<xml_diff>
--- a/samples/assets/pptx/pptx_image_single.pptx
+++ b/samples/assets/pptx/pptx_image_single.pptx
@@ -3088,30 +3088,45 @@
         <p:nvPr/>
       </p:nvGrpSpPr>
       <p:grpSpPr/>
-      <p:pic>
-        <p:nvPicPr>
-          <p:cNvPr id="2" name="Picture 1" descr="_tmp_single.png"/>
-          <p:cNvPicPr>
-            <a:picLocks noChangeAspect="1"/>
-          </p:cNvPicPr>
+      <p:grpSp>
+        <p:nvGrpSpPr>
+          <p:cNvPr id="200" name="Image Group"/>
+          <p:cNvGrpSpPr/>
           <p:nvPr/>
-        </p:nvPicPr>
-        <p:blipFill>
-          <a:blip r:embed="rId2"/>
-          <a:stretch>
-            <a:fillRect/>
-          </a:stretch>
-        </p:blipFill>
-        <p:spPr>
+        </p:nvGrpSpPr>
+        <p:grpSpPr>
           <a:xfrm>
-            <a:off x="1200000" y="900000"/>
-            <a:ext cx="4000000" cy="2500000"/>
+            <a:off x="0" y="0"/>
+            <a:ext cx="0" cy="0"/>
+            <a:chOff x="0" y="0"/>
+            <a:chExt cx="0" cy="0"/>
           </a:xfrm>
-          <a:prstGeom prst="rect">
-            <a:avLst/>
-          </a:prstGeom>
-        </p:spPr>
-      </p:pic>
+        </p:grpSpPr>
+        <p:pic>
+          <p:nvPicPr>
+            <p:cNvPr id="2" name="Picture 1" descr="_tmp_single.png"/>
+            <p:cNvPicPr>
+              <a:picLocks noChangeAspect="1"/>
+            </p:cNvPicPr>
+            <p:nvPr/>
+          </p:nvPicPr>
+          <p:blipFill>
+            <a:blip r:embed="rId2"/>
+            <a:stretch>
+              <a:fillRect/>
+            </a:stretch>
+          </p:blipFill>
+          <p:spPr>
+            <a:xfrm>
+              <a:off x="1200000" y="900000"/>
+              <a:ext cx="4000000" cy="2500000"/>
+            </a:xfrm>
+            <a:prstGeom prst="rect">
+              <a:avLst/>
+            </a:prstGeom>
+          </p:spPr>
+        </p:pic>
+      </p:grpSp>
     </p:spTree>
   </p:cSld>
   <p:clrMapOvr>

</xml_diff>